<commit_message>
Add confidence score and ranking repair pipelines
Introduced repair_with_confidence_score.py and repair_with_ranking.py for new answer selection strategies. Updated prompts.py to add CONFIDENCE_SCORE_PROMPT and RANKING_PROMPT, and renamed JUDGE_PROMPT to VOTING_PROMPT. Modified repair_with_mutation.py to use the new VOTING_PROMPT. Updated slides to reflect these changes.
</commit_message>
<xml_diff>
--- a/slides/20251218.pptx
+++ b/slides/20251218.pptx
@@ -3517,7 +3517,7 @@
         <p:spPr>
           <a:xfrm>
             <a:off x="479719" y="151179"/>
-            <a:ext cx="11219222" cy="3231654"/>
+            <a:ext cx="11219222" cy="4955203"/>
           </a:xfrm>
           <a:prstGeom prst="rect">
             <a:avLst/>
@@ -3634,11 +3634,75 @@
               <a:t>, 1067 samples from </a:t>
             </a:r>
             <a:r>
+              <a:rPr lang="en-US" altLang="zh-CN" sz="2000" dirty="0" err="1">
+                <a:latin typeface="Arial" panose="020B0604020202020204" pitchFamily="34" charset="0"/>
+                <a:cs typeface="Arial" panose="020B0604020202020204" pitchFamily="34" charset="0"/>
+              </a:rPr>
+              <a:t>HotpotQA</a:t>
+            </a:r>
+            <a:endParaRPr lang="en-US" altLang="zh-CN" sz="2000" dirty="0">
+              <a:latin typeface="Arial" panose="020B0604020202020204" pitchFamily="34" charset="0"/>
+              <a:cs typeface="Arial" panose="020B0604020202020204" pitchFamily="34" charset="0"/>
+            </a:endParaRPr>
+          </a:p>
+          <a:p>
+            <a:endParaRPr lang="en-US" altLang="zh-CN" sz="2000" dirty="0">
+              <a:latin typeface="Arial" panose="020B0604020202020204" pitchFamily="34" charset="0"/>
+              <a:cs typeface="Arial" panose="020B0604020202020204" pitchFamily="34" charset="0"/>
+            </a:endParaRPr>
+          </a:p>
+          <a:p>
+            <a:r>
+              <a:rPr lang="en-US" altLang="zh-CN" sz="3200" dirty="0">
+                <a:latin typeface="Arial" panose="020B0604020202020204" pitchFamily="34" charset="0"/>
+                <a:cs typeface="Arial" panose="020B0604020202020204" pitchFamily="34" charset="0"/>
+              </a:rPr>
+              <a:t>Final Experiment models:</a:t>
+            </a:r>
+          </a:p>
+          <a:p>
+            <a:endParaRPr lang="en-US" altLang="zh-CN" sz="2000" dirty="0">
+              <a:latin typeface="Arial" panose="020B0604020202020204" pitchFamily="34" charset="0"/>
+              <a:cs typeface="Arial" panose="020B0604020202020204" pitchFamily="34" charset="0"/>
+            </a:endParaRPr>
+          </a:p>
+          <a:p>
+            <a:r>
+              <a:rPr lang="en-US" altLang="zh-CN" sz="2000" dirty="0">
+                <a:latin typeface="Arial" panose="020B0604020202020204" pitchFamily="34" charset="0"/>
+                <a:cs typeface="Arial" panose="020B0604020202020204" pitchFamily="34" charset="0"/>
+              </a:rPr>
+              <a:t>open-source model: gemma-3</a:t>
+            </a:r>
+          </a:p>
+          <a:p>
+            <a:r>
+              <a:rPr lang="en-US" altLang="zh-CN" sz="2000" dirty="0">
+                <a:latin typeface="Arial" panose="020B0604020202020204" pitchFamily="34" charset="0"/>
+                <a:cs typeface="Arial" panose="020B0604020202020204" pitchFamily="34" charset="0"/>
+              </a:rPr>
+              <a:t>close-source models: gpt-4o, gpt-5, </a:t>
+            </a:r>
+            <a:r>
+              <a:rPr lang="en-US" altLang="zh-CN" sz="2000" dirty="0" err="1">
+                <a:latin typeface="Arial" panose="020B0604020202020204" pitchFamily="34" charset="0"/>
+                <a:cs typeface="Arial" panose="020B0604020202020204" pitchFamily="34" charset="0"/>
+              </a:rPr>
+              <a:t>gemini</a:t>
+            </a:r>
+            <a:r>
+              <a:rPr lang="en-US" altLang="zh-CN" sz="2000" dirty="0">
+                <a:latin typeface="Arial" panose="020B0604020202020204" pitchFamily="34" charset="0"/>
+                <a:cs typeface="Arial" panose="020B0604020202020204" pitchFamily="34" charset="0"/>
+              </a:rPr>
+              <a:t>-pro-latest</a:t>
+            </a:r>
+            <a:r>
               <a:rPr lang="en-US" altLang="zh-CN" sz="2000">
                 <a:latin typeface="Arial" panose="020B0604020202020204" pitchFamily="34" charset="0"/>
                 <a:cs typeface="Arial" panose="020B0604020202020204" pitchFamily="34" charset="0"/>
               </a:rPr>
-              <a:t>HotpotQA</a:t>
+              <a:t>, claude-sonnet-4-5</a:t>
             </a:r>
             <a:endParaRPr lang="en-US" altLang="zh-CN" sz="2000" dirty="0">
               <a:latin typeface="Arial" panose="020B0604020202020204" pitchFamily="34" charset="0"/>

</xml_diff>